<commit_message>
feat: add subscription management, executive brief export services, and related UI components with test suites
</commit_message>
<xml_diff>
--- a/Procucev_Procurement_Value_Savings_Diagnostic_Client_Alpha_2026-10-02.pptx
+++ b/Procucev_Procurement_Value_Savings_Diagnostic_Client_Alpha_2026-10-02.pptx
@@ -4945,8 +4945,8 @@
         </p:nvSpPr>
         <p:spPr>
           <a:xfrm>
-            <a:off x="594360" y="3584448"/>
-            <a:ext cx="3657600" cy="292608"/>
+            <a:off x="594360" y="3566160"/>
+            <a:ext cx="3657600" cy="329184"/>
           </a:xfrm>
           <a:prstGeom prst="rect">
             <a:avLst/>
@@ -5087,8 +5087,8 @@
         </p:nvSpPr>
         <p:spPr>
           <a:xfrm>
-            <a:off x="4846320" y="3584448"/>
-            <a:ext cx="3657600" cy="292608"/>
+            <a:off x="4846320" y="3566160"/>
+            <a:ext cx="3657600" cy="329184"/>
           </a:xfrm>
           <a:prstGeom prst="rect">
             <a:avLst/>

</xml_diff>